<commit_message>
L01 and L04: republish with the October 6 build deadline
L04 also picks up its rename to "Spec-Driven Development", which landed in
the term repo earlier and had never been shipped.

Co-Authored-By: Claude Opus 5 (1M context) <noreply@anthropic.com>
Claude-Session: https://claude.ai/code/session_01W93UZep7mkyr672vwh5gYS
</commit_message>
<xml_diff>
--- a/lectures/L04/slides.pptx
+++ b/lectures/L04/slides.pptx
@@ -5853,7 +5853,7 @@
               <a:t>Dates, said once and clearly. Setup gate and all sixteen aider-practice
 lessons are due tomorrow, Friday September 11. Lab01 is Monday September 14
 for the Monday section, Tuesday September 15 for the Tuesday section. The
-build is due Friday September 25.
+build is due Tuesday October 6 at 11:59 PM.
 Last click prevents a week of confusion. They are not building yet.
 aider-practice finishes this week and the build starts after Lab01.</a:t>
             </a:r>
@@ -5946,7 +5946,7 @@
               <a:t>Dates, said once and clearly. Setup gate and all sixteen aider-practice
 lessons are due tomorrow, Friday September 11. Lab01 is Monday September 14
 for the Monday section, Tuesday September 15 for the Tuesday section. The
-build is due Friday September 25.
+build is due Tuesday October 6 at 11:59 PM.
 Last click prevents a week of confusion. They are not building yet.
 aider-practice finishes this week and the build starts after Lab01.</a:t>
             </a:r>
@@ -6039,7 +6039,7 @@
               <a:t>Dates, said once and clearly. Setup gate and all sixteen aider-practice
 lessons are due tomorrow, Friday September 11. Lab01 is Monday September 14
 for the Monday section, Tuesday September 15 for the Tuesday section. The
-build is due Friday September 25.
+build is due Tuesday October 6 at 11:59 PM.
 Last click prevents a week of confusion. They are not building yet.
 aider-practice finishes this week and the build starts after Lab01.</a:t>
             </a:r>
@@ -6132,7 +6132,7 @@
               <a:t>Dates, said once and clearly. Setup gate and all sixteen aider-practice
 lessons are due tomorrow, Friday September 11. Lab01 is Monday September 14
 for the Monday section, Tuesday September 15 for the Tuesday section. The
-build is due Friday September 25.
+build is due Tuesday October 6 at 11:59 PM.
 Last click prevents a week of confusion. They are not building yet.
 aider-practice finishes this week and the build starts after Lab01.</a:t>
             </a:r>
@@ -6225,7 +6225,7 @@
               <a:t>Dates, said once and clearly. Setup gate and all sixteen aider-practice
 lessons are due tomorrow, Friday September 11. Lab01 is Monday September 14
 for the Monday section, Tuesday September 15 for the Tuesday section. The
-build is due Friday September 25.
+build is due Tuesday October 6 at 11:59 PM.
 Last click prevents a week of confusion. They are not building yet.
 aider-practice finishes this week and the build starts after Lab01.</a:t>
             </a:r>

</xml_diff>

<commit_message>
L01 and L04: republish with the October 6 build deadline (#8)
L04 also picks up its rename to "Spec-Driven Development", which landed in
the term repo earlier and had never been shipped.


Claude-Session: https://claude.ai/code/session_01W93UZep7mkyr672vwh5gYS

Co-authored-by: Claude <noreply@anthropic.com>
</commit_message>
<xml_diff>
--- a/lectures/L04/slides.pptx
+++ b/lectures/L04/slides.pptx
@@ -5853,7 +5853,7 @@
               <a:t>Dates, said once and clearly. Setup gate and all sixteen aider-practice
 lessons are due tomorrow, Friday September 11. Lab01 is Monday September 14
 for the Monday section, Tuesday September 15 for the Tuesday section. The
-build is due Friday September 25.
+build is due Tuesday October 6 at 11:59 PM.
 Last click prevents a week of confusion. They are not building yet.
 aider-practice finishes this week and the build starts after Lab01.</a:t>
             </a:r>
@@ -5946,7 +5946,7 @@
               <a:t>Dates, said once and clearly. Setup gate and all sixteen aider-practice
 lessons are due tomorrow, Friday September 11. Lab01 is Monday September 14
 for the Monday section, Tuesday September 15 for the Tuesday section. The
-build is due Friday September 25.
+build is due Tuesday October 6 at 11:59 PM.
 Last click prevents a week of confusion. They are not building yet.
 aider-practice finishes this week and the build starts after Lab01.</a:t>
             </a:r>
@@ -6039,7 +6039,7 @@
               <a:t>Dates, said once and clearly. Setup gate and all sixteen aider-practice
 lessons are due tomorrow, Friday September 11. Lab01 is Monday September 14
 for the Monday section, Tuesday September 15 for the Tuesday section. The
-build is due Friday September 25.
+build is due Tuesday October 6 at 11:59 PM.
 Last click prevents a week of confusion. They are not building yet.
 aider-practice finishes this week and the build starts after Lab01.</a:t>
             </a:r>
@@ -6132,7 +6132,7 @@
               <a:t>Dates, said once and clearly. Setup gate and all sixteen aider-practice
 lessons are due tomorrow, Friday September 11. Lab01 is Monday September 14
 for the Monday section, Tuesday September 15 for the Tuesday section. The
-build is due Friday September 25.
+build is due Tuesday October 6 at 11:59 PM.
 Last click prevents a week of confusion. They are not building yet.
 aider-practice finishes this week and the build starts after Lab01.</a:t>
             </a:r>
@@ -6225,7 +6225,7 @@
               <a:t>Dates, said once and clearly. Setup gate and all sixteen aider-practice
 lessons are due tomorrow, Friday September 11. Lab01 is Monday September 14
 for the Monday section, Tuesday September 15 for the Tuesday section. The
-build is due Friday September 25.
+build is due Tuesday October 6 at 11:59 PM.
 Last click prevents a week of confusion. They are not building yet.
 aider-practice finishes this week and the build starts after Lab01.</a:t>
             </a:r>

</xml_diff>

<commit_message>
L01 and L04: republish with the corrected packet description
Both public decks said the pair-programmer is built on a starter. There
is no starter; the packet is a specification and an Aider configuration.

Co-Authored-By: Claude Opus 5 (1M context) <noreply@anthropic.com>
Claude-Session: https://claude.ai/code/session_01W93UZep7mkyr672vwh5gYS
</commit_message>
<xml_diff>
--- a/lectures/L04/slides.pptx
+++ b/lectures/L04/slides.pptx
@@ -6325,7 +6325,7 @@
 have been driving for two weeks. F2 is /add and /drop, which is L03's demo,
 and F4 is the spec written for one small model, which is the next slide.
 Table matches Lab01's exactly, on purpose. The full spec with the checked
-behaviors is in the starter repo.</a:t>
+behaviors is in the packet repository they clone.</a:t>
             </a:r>
             <a:endParaRPr lang="en-US" dirty="0"/>
           </a:p>
@@ -6414,9 +6414,10 @@
             <a:r>
               <a:rPr lang="en-US" dirty="0"/>
               <a:t>Both cards are graded work, which is the label. Say that first.
-Left card: seven features on a starter is exactly the three or more files,
-building from scratch case from the decision rule, so the spec is a required
-deliverable.
+Left card: seven features with no starter code is exactly the three or more
+files, building from scratch case from the decision rule, so the spec is a
+required deliverable. Be plain that the packet ships no application code, no
+module layout and no tests.
 Right card is the one worth the time. F4 is the instruction that tells a
 model how to emit an edit. That is a spec written for an audience of one
 small model, and it is the least forgiving one all term. Leave it vague and

</xml_diff>

<commit_message>
L01 and L04: republish with the corrected packet description (#9)
Both public decks said the pair-programmer is built on a starter. There
is no starter; the packet is a specification and an Aider configuration.


Claude-Session: https://claude.ai/code/session_01W93UZep7mkyr672vwh5gYS

Co-authored-by: Claude <noreply@anthropic.com>
</commit_message>
<xml_diff>
--- a/lectures/L04/slides.pptx
+++ b/lectures/L04/slides.pptx
@@ -6325,7 +6325,7 @@
 have been driving for two weeks. F2 is /add and /drop, which is L03's demo,
 and F4 is the spec written for one small model, which is the next slide.
 Table matches Lab01's exactly, on purpose. The full spec with the checked
-behaviors is in the starter repo.</a:t>
+behaviors is in the packet repository they clone.</a:t>
             </a:r>
             <a:endParaRPr lang="en-US" dirty="0"/>
           </a:p>
@@ -6414,9 +6414,10 @@
             <a:r>
               <a:rPr lang="en-US" dirty="0"/>
               <a:t>Both cards are graded work, which is the label. Say that first.
-Left card: seven features on a starter is exactly the three or more files,
-building from scratch case from the decision rule, so the spec is a required
-deliverable.
+Left card: seven features with no starter code is exactly the three or more
+files, building from scratch case from the decision rule, so the spec is a
+required deliverable. Be plain that the packet ships no application code, no
+module layout and no tests.
 Right card is the one worth the time. F4 is the instruction that tells a
 model how to emit an edit. That is a spec written for an audience of one
 small model, and it is the least forgiving one all term. Leave it vague and

</xml_diff>